<commit_message>
chore: sync all pending site updates
</commit_message>
<xml_diff>
--- a/data/인공지능/00 - preview.pptx
+++ b/data/인공지능/00 - preview.pptx
@@ -331,7 +331,7 @@
       </p15:notesGuideLst>
     </p:ext>
     <p:ext uri="GoogleSlidesCustomDataVersion2">
-      <go:slidesCustomData xmlns:go="http://customooxmlschemas.google.com/" xmlns:ahyp="http://schemas.microsoft.com/office/drawing/2018/hyperlinkcolor" xmlns:p15="http://schemas.microsoft.com/office/powerpoint/2012/main" xmlns:p14="http://schemas.microsoft.com/office/powerpoint/2010/main" xmlns:com="http://schemas.openxmlformats.org/drawingml/2006/compatibility" xmlns:pvml="urn:schemas-microsoft-com:office:powerpoint" xmlns:v="urn:schemas-microsoft-com:vml" xmlns:o="urn:schemas-microsoft-com:office:office" xmlns:dgm="http://schemas.openxmlformats.org/drawingml/2006/diagram" xmlns:c="http://schemas.openxmlformats.org/drawingml/2006/chart" xmlns:mv="urn:schemas-microsoft-com:mac:vml" xmlns:mc="http://schemas.openxmlformats.org/markup-compatibility/2006" xmlns="" r:id="rId61" roundtripDataSignature="AMtx7mgQh/JTZB+tcnoesXfhZuEldfv5OQ=="/>
+      <go:slidesCustomData xmlns="" xmlns:mc="http://schemas.openxmlformats.org/markup-compatibility/2006" xmlns:mv="urn:schemas-microsoft-com:mac:vml" xmlns:c="http://schemas.openxmlformats.org/drawingml/2006/chart" xmlns:dgm="http://schemas.openxmlformats.org/drawingml/2006/diagram" xmlns:o="urn:schemas-microsoft-com:office:office" xmlns:v="urn:schemas-microsoft-com:vml" xmlns:pvml="urn:schemas-microsoft-com:office:powerpoint" xmlns:com="http://schemas.openxmlformats.org/drawingml/2006/compatibility" xmlns:p14="http://schemas.microsoft.com/office/powerpoint/2010/main" xmlns:p15="http://schemas.microsoft.com/office/powerpoint/2012/main" xmlns:ahyp="http://schemas.microsoft.com/office/drawing/2018/hyperlinkcolor" xmlns:go="http://customooxmlschemas.google.com/" r:id="rId61" roundtripDataSignature="AMtx7mgQh/JTZB+tcnoesXfhZuEldfv5OQ=="/>
     </p:ext>
   </p:extLst>
 </p:presentation>
@@ -12571,7 +12571,15 @@
             </a:r>
             <a:r>
               <a:rPr lang="ko-KR" altLang="en-US" sz="1600" dirty="0"/>
-              <a:t> 통한 기말 프로젝트 </a:t>
+              <a:t> 통한 </a:t>
+            </a:r>
+            <a:r>
+              <a:rPr lang="en-US" altLang="ko-KR" sz="1600" dirty="0"/>
+              <a:t>AI</a:t>
+            </a:r>
+            <a:r>
+              <a:rPr lang="ko-KR" altLang="en-US" sz="1600" dirty="0"/>
+              <a:t> 프로젝트 </a:t>
             </a:r>
             <a:r>
               <a:rPr lang="en-US" altLang="ko-KR" sz="1600" dirty="0"/>
@@ -12630,7 +12638,15 @@
             </a:r>
             <a:r>
               <a:rPr lang="ko-KR" altLang="en-US" sz="1600" dirty="0"/>
-              <a:t> 통한 기말 프로젝트 </a:t>
+              <a:t> 통한 </a:t>
+            </a:r>
+            <a:r>
+              <a:rPr lang="en-US" altLang="ko-KR" sz="1600" dirty="0"/>
+              <a:t>AI</a:t>
+            </a:r>
+            <a:r>
+              <a:rPr lang="ko-KR" altLang="en-US" sz="1600" dirty="0"/>
+              <a:t> 프로젝트 </a:t>
             </a:r>
             <a:r>
               <a:rPr lang="en-US" altLang="ko-KR" sz="1600" dirty="0"/>
@@ -12677,15 +12693,19 @@
             </a:r>
             <a:r>
               <a:rPr lang="ko-KR" altLang="en-US" sz="1600" dirty="0"/>
-              <a:t>보강 및 기말 프로젝트 </a:t>
+              <a:t>보강 및 </a:t>
             </a:r>
             <a:r>
               <a:rPr lang="en-US" altLang="ko-KR" sz="1600" dirty="0"/>
-              <a:t>(3)</a:t>
+              <a:t>AI</a:t>
+            </a:r>
+            <a:r>
+              <a:rPr lang="ko-KR" altLang="en-US" sz="1600"/>
+              <a:t> 프로젝트 </a:t>
             </a:r>
             <a:r>
               <a:rPr lang="ko-KR" altLang="en-US" sz="1600" dirty="0"/>
-              <a:t> 수행</a:t>
+              <a:t>수행</a:t>
             </a:r>
           </a:p>
           <a:p>

</xml_diff>